<commit_message>
Update to ML project report
</commit_message>
<xml_diff>
--- a/Machine Learning/Project/Presentation.pptx
+++ b/Machine Learning/Project/Presentation.pptx
@@ -130,6 +130,7 @@
   <p1510:revLst>
     <p1510:client id="{1DF47E20-187E-BE18-6978-4EB7FEBC7A4E}" v="53" dt="2023-12-08T00:04:57.381"/>
     <p1510:client id="{87CB8A24-5DAD-C802-9B7B-4CF8FA4A59D6}" v="322" dt="2023-12-08T05:17:52.177"/>
+    <p1510:client id="{8E828687-E844-5260-4D66-A37FFD7FCDE6}" v="6" dt="2023-12-08T05:37:04.208"/>
     <p1510:client id="{AACEE25D-C8E2-4731-AF0C-308637686D6B}" v="2" dt="2023-12-07T23:54:41.897"/>
   </p1510:revLst>
 </p1510:revInfo>
@@ -8669,26 +8670,26 @@
           </a:xfrm>
         </p:spPr>
         <p:txBody>
-          <a:bodyPr vert="horz" lIns="91440" tIns="45720" rIns="91440" bIns="45720" rtlCol="0">
+          <a:bodyPr vert="horz" lIns="91440" tIns="45720" rIns="91440" bIns="45720" rtlCol="0" anchor="t">
             <a:normAutofit/>
           </a:bodyPr>
           <a:lstStyle/>
           <a:p>
             <a:r>
-              <a:rPr lang="en-US"/>
+              <a:rPr lang="en-US" dirty="0"/>
               <a:t>0.5 testing accuracy seems to be the peak for point predictions</a:t>
             </a:r>
           </a:p>
           <a:p>
             <a:r>
-              <a:rPr lang="en-US"/>
+              <a:rPr lang="en-US" dirty="0"/>
               <a:t>Description-based predictions performed much better</a:t>
             </a:r>
           </a:p>
           <a:p>
             <a:r>
-              <a:rPr lang="en-US"/>
-              <a:t>Transformers performed the best at 0.83 testing accuracy with Recurrent Neural Networks close behind at 0.8</a:t>
+              <a:rPr lang="en-US" dirty="0"/>
+              <a:t>Transformers performed the best at 0.83 testing accuracy with Feedforward Neural Networks close behind at 0.8</a:t>
             </a:r>
           </a:p>
         </p:txBody>

</xml_diff>